<commit_message>
Move to kohli6/mcp-pulse: update links, citation and deck
</commit_message>
<xml_diff>
--- a/docs/presentation/MCP_Pulse_Streaming_Context.pptx
+++ b/docs/presentation/MCP_Pulse_Streaming_Context.pptx
@@ -7799,7 +7799,7 @@
           </a:p>
           <a:p>
             <a:r>
-              <a:t>github.com/hakohli/mcp-pulse</a:t>
+              <a:t>github.com/kohli6/mcp-pulse</a:t>
             </a:r>
           </a:p>
         </p:txBody>
@@ -8271,7 +8271,7 @@
           <a:lstStyle/>
           <a:p>
             <a:r>
-              <a:t>github.com/hakohli/mcp-pulse</a:t>
+              <a:t>github.com/kohli6/mcp-pulse</a:t>
             </a:r>
           </a:p>
           <a:p>

</xml_diff>